<commit_message>
Day 2 deck: section dividers review - warranty agenda line and chip about protecting the money
Co-Authored-By: Claude Opus 5.5 <noreply@anthropic.com>
Claude-Session: https://claude.ai/code/session_01Xa4nFVxuQGXmHARGph9WhS
</commit_message>
<xml_diff>
--- a/day2-deck/decks/Section Dividers - Review.pptx
+++ b/day2-deck/decks/Section Dividers - Review.pptx
@@ -2889,7 +2889,7 @@
                 <a:ea typeface="Inter" pitchFamily="34" charset="-122"/>
                 <a:cs typeface="Inter" pitchFamily="34" charset="-120"/>
               </a:rPr>
-              <a:t>Warranty rates, gross profit and compliance.</a:t>
+              <a:t>Warranty rates, margins and compliance: protecting the money.</a:t>
             </a:r>
             <a:endParaRPr lang="en-US" sz="1400" dirty="0"/>
           </a:p>
@@ -3219,7 +3219,7 @@
                 <a:ea typeface="Inter" pitchFamily="34" charset="-122"/>
                 <a:cs typeface="Inter" pitchFamily="34" charset="-120"/>
               </a:rPr>
-              <a:t>Rates rising   ·   Warranty gross profit   ·   Warranty audits</a:t>
+              <a:t>Rates rising   ·   Warranty gross profit   ·   Claim process: protect the money</a:t>
             </a:r>
             <a:endParaRPr lang="en-US" sz="2200" dirty="0"/>
           </a:p>

</xml_diff>